<commit_message>
feat(pitch): update PITCH documents with improved styling and content adjustments
</commit_message>
<xml_diff>
--- a/docs/pitch/PITCH.pptx
+++ b/docs/pitch/PITCH.pptx
@@ -13,20 +13,9 @@
     <p:sldId id="261" r:id="rId7"/>
     <p:sldId id="262" r:id="rId8"/>
     <p:sldId id="263" r:id="rId9"/>
-    <p:sldId id="264" r:id="rId10"/>
-    <p:sldId id="265" r:id="rId11"/>
-    <p:sldId id="266" r:id="rId12"/>
-    <p:sldId id="267" r:id="rId13"/>
-    <p:sldId id="268" r:id="rId14"/>
-    <p:sldId id="269" r:id="rId15"/>
-    <p:sldId id="270" r:id="rId16"/>
-    <p:sldId id="271" r:id="rId17"/>
-    <p:sldId id="272" r:id="rId18"/>
-    <p:sldId id="273" r:id="rId19"/>
-    <p:sldId id="274" r:id="rId20"/>
   </p:sldIdLst>
   <p:notesMasterIdLst>
-    <p:notesMasterId r:id="rId21"/>
+    <p:notesMasterId r:id="rId10"/>
   </p:notesMasterIdLst>
   <p:sldSz cx="12192000" cy="6858000"/>
   <p:notesSz cx="6858000" cy="12192000"/>
@@ -520,7 +509,7 @@
           <a:p>
             <a:r>
               <a:rPr lang="en-US" dirty="0"/>
-              <a:t>Спікер: Привіт. Челендж — моніторинг ризиків прав дитини. Сьогодні держава реагує постфактум, коли право вже порушено. Ми побудували платформу, яка з'єднує реєстри й бачить ризик заздалегідь. І покажемо це на гострому, грошовому прикладі — реформі профільної освіти 2027.</a:t>
+              <a:t>Спікер (0:00–0:25): Щороку держава вкладає десятки мільярдів у освіту, яка не конвертується в роботу за фахом — до 80% випускників. А права дитини на розвиток порушуються тихо, без сигналу. У 2027 реформа профілів зробить цей вибір ще дорожчим. Ми побудували систему, що ловить ризик заздалегідь.</a:t>
             </a:r>
             <a:endParaRPr lang="en-US" dirty="0"/>
           </a:p>
@@ -544,886 +533,6 @@
             <a:fld id="{F7021451-1387-4CA6-816F-3879F97B5CBC}" type="slidenum">
               <a:rPr lang="en-US"/>
               <a:t>1</a:t>
-            </a:fld>
-            <a:endParaRPr lang="en-US"/>
-          </a:p>
-        </p:txBody>
-      </p:sp>
-    </p:spTree>
-    <p:extLst>
-      <p:ext uri="{BB962C8B-B14F-4D97-AF65-F5344CB8AC3E}">
-        <p14:creationId xmlns:p14="http://schemas.microsoft.com/office/powerpoint/2010/main" val="1024086991"/>
-      </p:ext>
-    </p:extLst>
-  </p:cSld>
-  <p:clrMapOvr>
-    <a:masterClrMapping/>
-  </p:clrMapOvr>
-</p:notes>
-</file>
-
-<file path=ppt/notesSlides/notesSlide10.xml><?xml version="1.0" encoding="utf-8"?>
-<p:notes xmlns:a="http://schemas.openxmlformats.org/drawingml/2006/main" xmlns:r="http://schemas.openxmlformats.org/officeDocument/2006/relationships" xmlns:p="http://schemas.openxmlformats.org/presentationml/2006/main">
-  <p:cSld>
-    <p:spTree>
-      <p:nvGrpSpPr>
-        <p:cNvPr id="1" name=""/>
-        <p:cNvGrpSpPr/>
-        <p:nvPr/>
-      </p:nvGrpSpPr>
-      <p:grpSpPr>
-        <a:xfrm>
-          <a:off x="0" y="0"/>
-          <a:ext cx="0" cy="0"/>
-          <a:chOff x="0" y="0"/>
-          <a:chExt cx="0" cy="0"/>
-        </a:xfrm>
-      </p:grpSpPr>
-      <p:sp>
-        <p:nvSpPr>
-          <p:cNvPr id="2" name="Slide Image Placeholder 1"/>
-          <p:cNvSpPr>
-            <a:spLocks noGrp="1" noRot="1" noChangeAspect="1"/>
-          </p:cNvSpPr>
-          <p:nvPr>
-            <p:ph type="sldImg"/>
-          </p:nvPr>
-        </p:nvSpPr>
-        <p:spPr/>
-      </p:sp>
-      <p:sp>
-        <p:nvSpPr>
-          <p:cNvPr id="3" name="Notes Placeholder 2"/>
-          <p:cNvSpPr>
-            <a:spLocks noGrp="1"/>
-          </p:cNvSpPr>
-          <p:nvPr>
-            <p:ph type="body" idx="1"/>
-          </p:nvPr>
-        </p:nvSpPr>
-        <p:spPr/>
-        <p:txBody>
-          <a:bodyPr/>
-          <a:lstStyle/>
-          <a:p>
-            <a:r>
-              <a:rPr lang="en-US" dirty="0"/>
-              <a:t>Спікер: Прапорці — це світлофор із чіткою політикою на кожен колір. Ядро детерміноване й покрите тестами, тож воно надійне й пояснюване — критично для державної системи, де рішення треба обґрунтовувати.</a:t>
-            </a:r>
-            <a:endParaRPr lang="en-US" dirty="0"/>
-          </a:p>
-        </p:txBody>
-      </p:sp>
-      <p:sp>
-        <p:nvSpPr>
-          <p:cNvPr id="4" name="Slide Number Placeholder 3"/>
-          <p:cNvSpPr>
-            <a:spLocks noGrp="1"/>
-          </p:cNvSpPr>
-          <p:nvPr>
-            <p:ph type="sldNum" sz="quarter" idx="10"/>
-          </p:nvPr>
-        </p:nvSpPr>
-        <p:spPr/>
-        <p:txBody>
-          <a:bodyPr/>
-          <a:lstStyle/>
-          <a:p>
-            <a:fld id="{F7021451-1387-4CA6-816F-3879F97B5CBC}" type="slidenum">
-              <a:rPr lang="en-US"/>
-              <a:t>10</a:t>
-            </a:fld>
-            <a:endParaRPr lang="en-US"/>
-          </a:p>
-        </p:txBody>
-      </p:sp>
-    </p:spTree>
-    <p:extLst>
-      <p:ext uri="{BB962C8B-B14F-4D97-AF65-F5344CB8AC3E}">
-        <p14:creationId xmlns:p14="http://schemas.microsoft.com/office/powerpoint/2010/main" val="1024086991"/>
-      </p:ext>
-    </p:extLst>
-  </p:cSld>
-  <p:clrMapOvr>
-    <a:masterClrMapping/>
-  </p:clrMapOvr>
-</p:notes>
-</file>
-
-<file path=ppt/notesSlides/notesSlide11.xml><?xml version="1.0" encoding="utf-8"?>
-<p:notes xmlns:a="http://schemas.openxmlformats.org/drawingml/2006/main" xmlns:r="http://schemas.openxmlformats.org/officeDocument/2006/relationships" xmlns:p="http://schemas.openxmlformats.org/presentationml/2006/main">
-  <p:cSld>
-    <p:spTree>
-      <p:nvGrpSpPr>
-        <p:cNvPr id="1" name=""/>
-        <p:cNvGrpSpPr/>
-        <p:nvPr/>
-      </p:nvGrpSpPr>
-      <p:grpSpPr>
-        <a:xfrm>
-          <a:off x="0" y="0"/>
-          <a:ext cx="0" cy="0"/>
-          <a:chOff x="0" y="0"/>
-          <a:chExt cx="0" cy="0"/>
-        </a:xfrm>
-      </p:grpSpPr>
-      <p:sp>
-        <p:nvSpPr>
-          <p:cNvPr id="2" name="Slide Image Placeholder 1"/>
-          <p:cNvSpPr>
-            <a:spLocks noGrp="1" noRot="1" noChangeAspect="1"/>
-          </p:cNvSpPr>
-          <p:nvPr>
-            <p:ph type="sldImg"/>
-          </p:nvPr>
-        </p:nvSpPr>
-        <p:spPr/>
-      </p:sp>
-      <p:sp>
-        <p:nvSpPr>
-          <p:cNvPr id="3" name="Notes Placeholder 2"/>
-          <p:cNvSpPr>
-            <a:spLocks noGrp="1"/>
-          </p:cNvSpPr>
-          <p:nvPr>
-            <p:ph type="body" idx="1"/>
-          </p:nvPr>
-        </p:nvSpPr>
-        <p:spPr/>
-        <p:txBody>
-          <a:bodyPr/>
-          <a:lstStyle/>
-          <a:p>
-            <a:r>
-              <a:rPr lang="en-US" dirty="0"/>
-              <a:t>Спікер: Це серце «по профілю не спрацьовує». Ми не вгадуємо — рахуємо по темах із згладжуванням, рекомендуємо кластер і ловимо розбіжність із бажанням дитини. Приклад Марії — у демо.</a:t>
-            </a:r>
-            <a:endParaRPr lang="en-US" dirty="0"/>
-          </a:p>
-        </p:txBody>
-      </p:sp>
-      <p:sp>
-        <p:nvSpPr>
-          <p:cNvPr id="4" name="Slide Number Placeholder 3"/>
-          <p:cNvSpPr>
-            <a:spLocks noGrp="1"/>
-          </p:cNvSpPr>
-          <p:nvPr>
-            <p:ph type="sldNum" sz="quarter" idx="10"/>
-          </p:nvPr>
-        </p:nvSpPr>
-        <p:spPr/>
-        <p:txBody>
-          <a:bodyPr/>
-          <a:lstStyle/>
-          <a:p>
-            <a:fld id="{F7021451-1387-4CA6-816F-3879F97B5CBC}" type="slidenum">
-              <a:rPr lang="en-US"/>
-              <a:t>11</a:t>
-            </a:fld>
-            <a:endParaRPr lang="en-US"/>
-          </a:p>
-        </p:txBody>
-      </p:sp>
-    </p:spTree>
-    <p:extLst>
-      <p:ext uri="{BB962C8B-B14F-4D97-AF65-F5344CB8AC3E}">
-        <p14:creationId xmlns:p14="http://schemas.microsoft.com/office/powerpoint/2010/main" val="1024086991"/>
-      </p:ext>
-    </p:extLst>
-  </p:cSld>
-  <p:clrMapOvr>
-    <a:masterClrMapping/>
-  </p:clrMapOvr>
-</p:notes>
-</file>
-
-<file path=ppt/notesSlides/notesSlide12.xml><?xml version="1.0" encoding="utf-8"?>
-<p:notes xmlns:a="http://schemas.openxmlformats.org/drawingml/2006/main" xmlns:r="http://schemas.openxmlformats.org/officeDocument/2006/relationships" xmlns:p="http://schemas.openxmlformats.org/presentationml/2006/main">
-  <p:cSld>
-    <p:spTree>
-      <p:nvGrpSpPr>
-        <p:cNvPr id="1" name=""/>
-        <p:cNvGrpSpPr/>
-        <p:nvPr/>
-      </p:nvGrpSpPr>
-      <p:grpSpPr>
-        <a:xfrm>
-          <a:off x="0" y="0"/>
-          <a:ext cx="0" cy="0"/>
-          <a:chOff x="0" y="0"/>
-          <a:chExt cx="0" cy="0"/>
-        </a:xfrm>
-      </p:grpSpPr>
-      <p:sp>
-        <p:nvSpPr>
-          <p:cNvPr id="2" name="Slide Image Placeholder 1"/>
-          <p:cNvSpPr>
-            <a:spLocks noGrp="1" noRot="1" noChangeAspect="1"/>
-          </p:cNvSpPr>
-          <p:nvPr>
-            <p:ph type="sldImg"/>
-          </p:nvPr>
-        </p:nvSpPr>
-        <p:spPr/>
-      </p:sp>
-      <p:sp>
-        <p:nvSpPr>
-          <p:cNvPr id="3" name="Notes Placeholder 2"/>
-          <p:cNvSpPr>
-            <a:spLocks noGrp="1"/>
-          </p:cNvSpPr>
-          <p:nvPr>
-            <p:ph type="body" idx="1"/>
-          </p:nvPr>
-        </p:nvSpPr>
-        <p:spPr/>
-        <p:txBody>
-          <a:bodyPr/>
-          <a:lstStyle/>
-          <a:p>
-            <a:r>
-              <a:rPr lang="en-US" dirty="0"/>
-              <a:t>Спікер: Виявити ризик мало — челендж хоче адресну відповідь. Ми даємо дитині конкретний план, а вишам і громадам — знеособлений попит для планування місць. Це і є проактивне втручання.</a:t>
-            </a:r>
-            <a:endParaRPr lang="en-US" dirty="0"/>
-          </a:p>
-        </p:txBody>
-      </p:sp>
-      <p:sp>
-        <p:nvSpPr>
-          <p:cNvPr id="4" name="Slide Number Placeholder 3"/>
-          <p:cNvSpPr>
-            <a:spLocks noGrp="1"/>
-          </p:cNvSpPr>
-          <p:nvPr>
-            <p:ph type="sldNum" sz="quarter" idx="10"/>
-          </p:nvPr>
-        </p:nvSpPr>
-        <p:spPr/>
-        <p:txBody>
-          <a:bodyPr/>
-          <a:lstStyle/>
-          <a:p>
-            <a:fld id="{F7021451-1387-4CA6-816F-3879F97B5CBC}" type="slidenum">
-              <a:rPr lang="en-US"/>
-              <a:t>12</a:t>
-            </a:fld>
-            <a:endParaRPr lang="en-US"/>
-          </a:p>
-        </p:txBody>
-      </p:sp>
-    </p:spTree>
-    <p:extLst>
-      <p:ext uri="{BB962C8B-B14F-4D97-AF65-F5344CB8AC3E}">
-        <p14:creationId xmlns:p14="http://schemas.microsoft.com/office/powerpoint/2010/main" val="1024086991"/>
-      </p:ext>
-    </p:extLst>
-  </p:cSld>
-  <p:clrMapOvr>
-    <a:masterClrMapping/>
-  </p:clrMapOvr>
-</p:notes>
-</file>
-
-<file path=ppt/notesSlides/notesSlide13.xml><?xml version="1.0" encoding="utf-8"?>
-<p:notes xmlns:a="http://schemas.openxmlformats.org/drawingml/2006/main" xmlns:r="http://schemas.openxmlformats.org/officeDocument/2006/relationships" xmlns:p="http://schemas.openxmlformats.org/presentationml/2006/main">
-  <p:cSld>
-    <p:spTree>
-      <p:nvGrpSpPr>
-        <p:cNvPr id="1" name=""/>
-        <p:cNvGrpSpPr/>
-        <p:nvPr/>
-      </p:nvGrpSpPr>
-      <p:grpSpPr>
-        <a:xfrm>
-          <a:off x="0" y="0"/>
-          <a:ext cx="0" cy="0"/>
-          <a:chOff x="0" y="0"/>
-          <a:chExt cx="0" cy="0"/>
-        </a:xfrm>
-      </p:grpSpPr>
-      <p:sp>
-        <p:nvSpPr>
-          <p:cNvPr id="2" name="Slide Image Placeholder 1"/>
-          <p:cNvSpPr>
-            <a:spLocks noGrp="1" noRot="1" noChangeAspect="1"/>
-          </p:cNvSpPr>
-          <p:nvPr>
-            <p:ph type="sldImg"/>
-          </p:nvPr>
-        </p:nvSpPr>
-        <p:spPr/>
-      </p:sp>
-      <p:sp>
-        <p:nvSpPr>
-          <p:cNvPr id="3" name="Notes Placeholder 2"/>
-          <p:cNvSpPr>
-            <a:spLocks noGrp="1"/>
-          </p:cNvSpPr>
-          <p:nvPr>
-            <p:ph type="body" idx="1"/>
-          </p:nvPr>
-        </p:nvSpPr>
-        <p:spPr/>
-        <p:txBody>
-          <a:bodyPr/>
-          <a:lstStyle/>
-          <a:p>
-            <a:r>
-              <a:rPr lang="en-US" dirty="0"/>
-              <a:t>Спікер: Тут закриваємо case management. Red автоматично перетворюється на направлення й кейс. Прибираємо «людський провал координації» між відомствами — головну причину реактивності.</a:t>
-            </a:r>
-            <a:endParaRPr lang="en-US" dirty="0"/>
-          </a:p>
-        </p:txBody>
-      </p:sp>
-      <p:sp>
-        <p:nvSpPr>
-          <p:cNvPr id="4" name="Slide Number Placeholder 3"/>
-          <p:cNvSpPr>
-            <a:spLocks noGrp="1"/>
-          </p:cNvSpPr>
-          <p:nvPr>
-            <p:ph type="sldNum" sz="quarter" idx="10"/>
-          </p:nvPr>
-        </p:nvSpPr>
-        <p:spPr/>
-        <p:txBody>
-          <a:bodyPr/>
-          <a:lstStyle/>
-          <a:p>
-            <a:fld id="{F7021451-1387-4CA6-816F-3879F97B5CBC}" type="slidenum">
-              <a:rPr lang="en-US"/>
-              <a:t>13</a:t>
-            </a:fld>
-            <a:endParaRPr lang="en-US"/>
-          </a:p>
-        </p:txBody>
-      </p:sp>
-    </p:spTree>
-    <p:extLst>
-      <p:ext uri="{BB962C8B-B14F-4D97-AF65-F5344CB8AC3E}">
-        <p14:creationId xmlns:p14="http://schemas.microsoft.com/office/powerpoint/2010/main" val="1024086991"/>
-      </p:ext>
-    </p:extLst>
-  </p:cSld>
-  <p:clrMapOvr>
-    <a:masterClrMapping/>
-  </p:clrMapOvr>
-</p:notes>
-</file>
-
-<file path=ppt/notesSlides/notesSlide14.xml><?xml version="1.0" encoding="utf-8"?>
-<p:notes xmlns:a="http://schemas.openxmlformats.org/drawingml/2006/main" xmlns:r="http://schemas.openxmlformats.org/officeDocument/2006/relationships" xmlns:p="http://schemas.openxmlformats.org/presentationml/2006/main">
-  <p:cSld>
-    <p:spTree>
-      <p:nvGrpSpPr>
-        <p:cNvPr id="1" name=""/>
-        <p:cNvGrpSpPr/>
-        <p:nvPr/>
-      </p:nvGrpSpPr>
-      <p:grpSpPr>
-        <a:xfrm>
-          <a:off x="0" y="0"/>
-          <a:ext cx="0" cy="0"/>
-          <a:chOff x="0" y="0"/>
-          <a:chExt cx="0" cy="0"/>
-        </a:xfrm>
-      </p:grpSpPr>
-      <p:sp>
-        <p:nvSpPr>
-          <p:cNvPr id="2" name="Slide Image Placeholder 1"/>
-          <p:cNvSpPr>
-            <a:spLocks noGrp="1" noRot="1" noChangeAspect="1"/>
-          </p:cNvSpPr>
-          <p:nvPr>
-            <p:ph type="sldImg"/>
-          </p:nvPr>
-        </p:nvSpPr>
-        <p:spPr/>
-      </p:sp>
-      <p:sp>
-        <p:nvSpPr>
-          <p:cNvPr id="3" name="Notes Placeholder 2"/>
-          <p:cNvSpPr>
-            <a:spLocks noGrp="1"/>
-          </p:cNvSpPr>
-          <p:nvPr>
-            <p:ph type="body" idx="1"/>
-          </p:nvPr>
-        </p:nvSpPr>
-        <p:spPr/>
-        <p:txBody>
-          <a:bodyPr/>
-          <a:lstStyle/>
-          <a:p>
-            <a:r>
-              <a:rPr lang="en-US" dirty="0"/>
-              <a:t>Спікер: Дашборд для управлінців — і одразу знімаємо головне заперечення журі: дані дітей. Рольовий доступ, територіальний скоуп, знеособлення попиту. Приватність вшита, а не пришита.</a:t>
-            </a:r>
-            <a:endParaRPr lang="en-US" dirty="0"/>
-          </a:p>
-        </p:txBody>
-      </p:sp>
-      <p:sp>
-        <p:nvSpPr>
-          <p:cNvPr id="4" name="Slide Number Placeholder 3"/>
-          <p:cNvSpPr>
-            <a:spLocks noGrp="1"/>
-          </p:cNvSpPr>
-          <p:nvPr>
-            <p:ph type="sldNum" sz="quarter" idx="10"/>
-          </p:nvPr>
-        </p:nvSpPr>
-        <p:spPr/>
-        <p:txBody>
-          <a:bodyPr/>
-          <a:lstStyle/>
-          <a:p>
-            <a:fld id="{F7021451-1387-4CA6-816F-3879F97B5CBC}" type="slidenum">
-              <a:rPr lang="en-US"/>
-              <a:t>14</a:t>
-            </a:fld>
-            <a:endParaRPr lang="en-US"/>
-          </a:p>
-        </p:txBody>
-      </p:sp>
-    </p:spTree>
-    <p:extLst>
-      <p:ext uri="{BB962C8B-B14F-4D97-AF65-F5344CB8AC3E}">
-        <p14:creationId xmlns:p14="http://schemas.microsoft.com/office/powerpoint/2010/main" val="1024086991"/>
-      </p:ext>
-    </p:extLst>
-  </p:cSld>
-  <p:clrMapOvr>
-    <a:masterClrMapping/>
-  </p:clrMapOvr>
-</p:notes>
-</file>
-
-<file path=ppt/notesSlides/notesSlide15.xml><?xml version="1.0" encoding="utf-8"?>
-<p:notes xmlns:a="http://schemas.openxmlformats.org/drawingml/2006/main" xmlns:r="http://schemas.openxmlformats.org/officeDocument/2006/relationships" xmlns:p="http://schemas.openxmlformats.org/presentationml/2006/main">
-  <p:cSld>
-    <p:spTree>
-      <p:nvGrpSpPr>
-        <p:cNvPr id="1" name=""/>
-        <p:cNvGrpSpPr/>
-        <p:nvPr/>
-      </p:nvGrpSpPr>
-      <p:grpSpPr>
-        <a:xfrm>
-          <a:off x="0" y="0"/>
-          <a:ext cx="0" cy="0"/>
-          <a:chOff x="0" y="0"/>
-          <a:chExt cx="0" cy="0"/>
-        </a:xfrm>
-      </p:grpSpPr>
-      <p:sp>
-        <p:nvSpPr>
-          <p:cNvPr id="2" name="Slide Image Placeholder 1"/>
-          <p:cNvSpPr>
-            <a:spLocks noGrp="1" noRot="1" noChangeAspect="1"/>
-          </p:cNvSpPr>
-          <p:nvPr>
-            <p:ph type="sldImg"/>
-          </p:nvPr>
-        </p:nvSpPr>
-        <p:spPr/>
-      </p:sp>
-      <p:sp>
-        <p:nvSpPr>
-          <p:cNvPr id="3" name="Notes Placeholder 2"/>
-          <p:cNvSpPr>
-            <a:spLocks noGrp="1"/>
-          </p:cNvSpPr>
-          <p:nvPr>
-            <p:ph type="body" idx="1"/>
-          </p:nvPr>
-        </p:nvSpPr>
-        <p:spPr/>
-        <p:txBody>
-          <a:bodyPr/>
-          <a:lstStyle/>
-          <a:p>
-            <a:r>
-              <a:rPr lang="en-US" dirty="0"/>
-              <a:t>Спікер: Це наш живий сценарій одним скриптом. Олег — відвідування. Марія — профільний мисмеч і повний маршрут виправлення. Медицина й булінг — міжвідомча ескалація в реальні кейси. За дві хвилини видно всю екосистему в дії.</a:t>
-            </a:r>
-            <a:endParaRPr lang="en-US" dirty="0"/>
-          </a:p>
-        </p:txBody>
-      </p:sp>
-      <p:sp>
-        <p:nvSpPr>
-          <p:cNvPr id="4" name="Slide Number Placeholder 3"/>
-          <p:cNvSpPr>
-            <a:spLocks noGrp="1"/>
-          </p:cNvSpPr>
-          <p:nvPr>
-            <p:ph type="sldNum" sz="quarter" idx="10"/>
-          </p:nvPr>
-        </p:nvSpPr>
-        <p:spPr/>
-        <p:txBody>
-          <a:bodyPr/>
-          <a:lstStyle/>
-          <a:p>
-            <a:fld id="{F7021451-1387-4CA6-816F-3879F97B5CBC}" type="slidenum">
-              <a:rPr lang="en-US"/>
-              <a:t>15</a:t>
-            </a:fld>
-            <a:endParaRPr lang="en-US"/>
-          </a:p>
-        </p:txBody>
-      </p:sp>
-    </p:spTree>
-    <p:extLst>
-      <p:ext uri="{BB962C8B-B14F-4D97-AF65-F5344CB8AC3E}">
-        <p14:creationId xmlns:p14="http://schemas.microsoft.com/office/powerpoint/2010/main" val="1024086991"/>
-      </p:ext>
-    </p:extLst>
-  </p:cSld>
-  <p:clrMapOvr>
-    <a:masterClrMapping/>
-  </p:clrMapOvr>
-</p:notes>
-</file>
-
-<file path=ppt/notesSlides/notesSlide16.xml><?xml version="1.0" encoding="utf-8"?>
-<p:notes xmlns:a="http://schemas.openxmlformats.org/drawingml/2006/main" xmlns:r="http://schemas.openxmlformats.org/officeDocument/2006/relationships" xmlns:p="http://schemas.openxmlformats.org/presentationml/2006/main">
-  <p:cSld>
-    <p:spTree>
-      <p:nvGrpSpPr>
-        <p:cNvPr id="1" name=""/>
-        <p:cNvGrpSpPr/>
-        <p:nvPr/>
-      </p:nvGrpSpPr>
-      <p:grpSpPr>
-        <a:xfrm>
-          <a:off x="0" y="0"/>
-          <a:ext cx="0" cy="0"/>
-          <a:chOff x="0" y="0"/>
-          <a:chExt cx="0" cy="0"/>
-        </a:xfrm>
-      </p:grpSpPr>
-      <p:sp>
-        <p:nvSpPr>
-          <p:cNvPr id="2" name="Slide Image Placeholder 1"/>
-          <p:cNvSpPr>
-            <a:spLocks noGrp="1" noRot="1" noChangeAspect="1"/>
-          </p:cNvSpPr>
-          <p:nvPr>
-            <p:ph type="sldImg"/>
-          </p:nvPr>
-        </p:nvSpPr>
-        <p:spPr/>
-      </p:sp>
-      <p:sp>
-        <p:nvSpPr>
-          <p:cNvPr id="3" name="Notes Placeholder 2"/>
-          <p:cNvSpPr>
-            <a:spLocks noGrp="1"/>
-          </p:cNvSpPr>
-          <p:nvPr>
-            <p:ph type="body" idx="1"/>
-          </p:nvPr>
-        </p:nvSpPr>
-        <p:spPr/>
-        <p:txBody>
-          <a:bodyPr/>
-          <a:lstStyle/>
-          <a:p>
-            <a:r>
-              <a:rPr lang="en-US" dirty="0"/>
-              <a:t>Спікер: Не обіцяємо чудес. Показуємо: будь-яке раннє наведення вперше розвертає криву вниз. Кожен пункт — це і гроші, і діти. Свідомо консервативно — щоб цифрам можна було вірити.</a:t>
-            </a:r>
-            <a:endParaRPr lang="en-US" dirty="0"/>
-          </a:p>
-        </p:txBody>
-      </p:sp>
-      <p:sp>
-        <p:nvSpPr>
-          <p:cNvPr id="4" name="Slide Number Placeholder 3"/>
-          <p:cNvSpPr>
-            <a:spLocks noGrp="1"/>
-          </p:cNvSpPr>
-          <p:nvPr>
-            <p:ph type="sldNum" sz="quarter" idx="10"/>
-          </p:nvPr>
-        </p:nvSpPr>
-        <p:spPr/>
-        <p:txBody>
-          <a:bodyPr/>
-          <a:lstStyle/>
-          <a:p>
-            <a:fld id="{F7021451-1387-4CA6-816F-3879F97B5CBC}" type="slidenum">
-              <a:rPr lang="en-US"/>
-              <a:t>16</a:t>
-            </a:fld>
-            <a:endParaRPr lang="en-US"/>
-          </a:p>
-        </p:txBody>
-      </p:sp>
-    </p:spTree>
-    <p:extLst>
-      <p:ext uri="{BB962C8B-B14F-4D97-AF65-F5344CB8AC3E}">
-        <p14:creationId xmlns:p14="http://schemas.microsoft.com/office/powerpoint/2010/main" val="1024086991"/>
-      </p:ext>
-    </p:extLst>
-  </p:cSld>
-  <p:clrMapOvr>
-    <a:masterClrMapping/>
-  </p:clrMapOvr>
-</p:notes>
-</file>
-
-<file path=ppt/notesSlides/notesSlide17.xml><?xml version="1.0" encoding="utf-8"?>
-<p:notes xmlns:a="http://schemas.openxmlformats.org/drawingml/2006/main" xmlns:r="http://schemas.openxmlformats.org/officeDocument/2006/relationships" xmlns:p="http://schemas.openxmlformats.org/presentationml/2006/main">
-  <p:cSld>
-    <p:spTree>
-      <p:nvGrpSpPr>
-        <p:cNvPr id="1" name=""/>
-        <p:cNvGrpSpPr/>
-        <p:nvPr/>
-      </p:nvGrpSpPr>
-      <p:grpSpPr>
-        <a:xfrm>
-          <a:off x="0" y="0"/>
-          <a:ext cx="0" cy="0"/>
-          <a:chOff x="0" y="0"/>
-          <a:chExt cx="0" cy="0"/>
-        </a:xfrm>
-      </p:grpSpPr>
-      <p:sp>
-        <p:nvSpPr>
-          <p:cNvPr id="2" name="Slide Image Placeholder 1"/>
-          <p:cNvSpPr>
-            <a:spLocks noGrp="1" noRot="1" noChangeAspect="1"/>
-          </p:cNvSpPr>
-          <p:nvPr>
-            <p:ph type="sldImg"/>
-          </p:nvPr>
-        </p:nvSpPr>
-        <p:spPr/>
-      </p:sp>
-      <p:sp>
-        <p:nvSpPr>
-          <p:cNvPr id="3" name="Notes Placeholder 2"/>
-          <p:cNvSpPr>
-            <a:spLocks noGrp="1"/>
-          </p:cNvSpPr>
-          <p:nvPr>
-            <p:ph type="body" idx="1"/>
-          </p:nvPr>
-        </p:nvSpPr>
-        <p:spPr/>
-        <p:txBody>
-          <a:bodyPr/>
-          <a:lstStyle/>
-          <a:p>
-            <a:r>
-              <a:rPr lang="en-US" dirty="0"/>
-              <a:t>Спікер: Чому нам можна довірити пілот. Це працюючий, тестований, масштабований бекенд, змодельований під реформу 2027 — а не презентація майбутнього.</a:t>
-            </a:r>
-            <a:endParaRPr lang="en-US" dirty="0"/>
-          </a:p>
-        </p:txBody>
-      </p:sp>
-      <p:sp>
-        <p:nvSpPr>
-          <p:cNvPr id="4" name="Slide Number Placeholder 3"/>
-          <p:cNvSpPr>
-            <a:spLocks noGrp="1"/>
-          </p:cNvSpPr>
-          <p:nvPr>
-            <p:ph type="sldNum" sz="quarter" idx="10"/>
-          </p:nvPr>
-        </p:nvSpPr>
-        <p:spPr/>
-        <p:txBody>
-          <a:bodyPr/>
-          <a:lstStyle/>
-          <a:p>
-            <a:fld id="{F7021451-1387-4CA6-816F-3879F97B5CBC}" type="slidenum">
-              <a:rPr lang="en-US"/>
-              <a:t>17</a:t>
-            </a:fld>
-            <a:endParaRPr lang="en-US"/>
-          </a:p>
-        </p:txBody>
-      </p:sp>
-    </p:spTree>
-    <p:extLst>
-      <p:ext uri="{BB962C8B-B14F-4D97-AF65-F5344CB8AC3E}">
-        <p14:creationId xmlns:p14="http://schemas.microsoft.com/office/powerpoint/2010/main" val="1024086991"/>
-      </p:ext>
-    </p:extLst>
-  </p:cSld>
-  <p:clrMapOvr>
-    <a:masterClrMapping/>
-  </p:clrMapOvr>
-</p:notes>
-</file>
-
-<file path=ppt/notesSlides/notesSlide18.xml><?xml version="1.0" encoding="utf-8"?>
-<p:notes xmlns:a="http://schemas.openxmlformats.org/drawingml/2006/main" xmlns:r="http://schemas.openxmlformats.org/officeDocument/2006/relationships" xmlns:p="http://schemas.openxmlformats.org/presentationml/2006/main">
-  <p:cSld>
-    <p:spTree>
-      <p:nvGrpSpPr>
-        <p:cNvPr id="1" name=""/>
-        <p:cNvGrpSpPr/>
-        <p:nvPr/>
-      </p:nvGrpSpPr>
-      <p:grpSpPr>
-        <a:xfrm>
-          <a:off x="0" y="0"/>
-          <a:ext cx="0" cy="0"/>
-          <a:chOff x="0" y="0"/>
-          <a:chExt cx="0" cy="0"/>
-        </a:xfrm>
-      </p:grpSpPr>
-      <p:sp>
-        <p:nvSpPr>
-          <p:cNvPr id="2" name="Slide Image Placeholder 1"/>
-          <p:cNvSpPr>
-            <a:spLocks noGrp="1" noRot="1" noChangeAspect="1"/>
-          </p:cNvSpPr>
-          <p:nvPr>
-            <p:ph type="sldImg"/>
-          </p:nvPr>
-        </p:nvSpPr>
-        <p:spPr/>
-      </p:sp>
-      <p:sp>
-        <p:nvSpPr>
-          <p:cNvPr id="3" name="Notes Placeholder 2"/>
-          <p:cNvSpPr>
-            <a:spLocks noGrp="1"/>
-          </p:cNvSpPr>
-          <p:nvPr>
-            <p:ph type="body" idx="1"/>
-          </p:nvPr>
-        </p:nvSpPr>
-        <p:spPr/>
-        <p:txBody>
-          <a:bodyPr/>
-          <a:lstStyle/>
-          <a:p>
-            <a:r>
-              <a:rPr lang="en-US" dirty="0"/>
-              <a:t>Спікер: Підсумок. Просимо пілот і тестові дані. Обіцяємо: ранній сигнал по кожній дитині замість реакції на кризу. Дякую — готові до запитань.</a:t>
-            </a:r>
-            <a:endParaRPr lang="en-US" dirty="0"/>
-          </a:p>
-        </p:txBody>
-      </p:sp>
-      <p:sp>
-        <p:nvSpPr>
-          <p:cNvPr id="4" name="Slide Number Placeholder 3"/>
-          <p:cNvSpPr>
-            <a:spLocks noGrp="1"/>
-          </p:cNvSpPr>
-          <p:nvPr>
-            <p:ph type="sldNum" sz="quarter" idx="10"/>
-          </p:nvPr>
-        </p:nvSpPr>
-        <p:spPr/>
-        <p:txBody>
-          <a:bodyPr/>
-          <a:lstStyle/>
-          <a:p>
-            <a:fld id="{F7021451-1387-4CA6-816F-3879F97B5CBC}" type="slidenum">
-              <a:rPr lang="en-US"/>
-              <a:t>18</a:t>
-            </a:fld>
-            <a:endParaRPr lang="en-US"/>
-          </a:p>
-        </p:txBody>
-      </p:sp>
-    </p:spTree>
-    <p:extLst>
-      <p:ext uri="{BB962C8B-B14F-4D97-AF65-F5344CB8AC3E}">
-        <p14:creationId xmlns:p14="http://schemas.microsoft.com/office/powerpoint/2010/main" val="1024086991"/>
-      </p:ext>
-    </p:extLst>
-  </p:cSld>
-  <p:clrMapOvr>
-    <a:masterClrMapping/>
-  </p:clrMapOvr>
-</p:notes>
-</file>
-
-<file path=ppt/notesSlides/notesSlide19.xml><?xml version="1.0" encoding="utf-8"?>
-<p:notes xmlns:a="http://schemas.openxmlformats.org/drawingml/2006/main" xmlns:r="http://schemas.openxmlformats.org/officeDocument/2006/relationships" xmlns:p="http://schemas.openxmlformats.org/presentationml/2006/main">
-  <p:cSld>
-    <p:spTree>
-      <p:nvGrpSpPr>
-        <p:cNvPr id="1" name=""/>
-        <p:cNvGrpSpPr/>
-        <p:nvPr/>
-      </p:nvGrpSpPr>
-      <p:grpSpPr>
-        <a:xfrm>
-          <a:off x="0" y="0"/>
-          <a:ext cx="0" cy="0"/>
-          <a:chOff x="0" y="0"/>
-          <a:chExt cx="0" cy="0"/>
-        </a:xfrm>
-      </p:grpSpPr>
-      <p:sp>
-        <p:nvSpPr>
-          <p:cNvPr id="2" name="Slide Image Placeholder 1"/>
-          <p:cNvSpPr>
-            <a:spLocks noGrp="1" noRot="1" noChangeAspect="1"/>
-          </p:cNvSpPr>
-          <p:nvPr>
-            <p:ph type="sldImg"/>
-          </p:nvPr>
-        </p:nvSpPr>
-        <p:spPr/>
-      </p:sp>
-      <p:sp>
-        <p:nvSpPr>
-          <p:cNvPr id="3" name="Notes Placeholder 2"/>
-          <p:cNvSpPr>
-            <a:spLocks noGrp="1"/>
-          </p:cNvSpPr>
-          <p:nvPr>
-            <p:ph type="body" idx="1"/>
-          </p:nvPr>
-        </p:nvSpPr>
-        <p:spPr/>
-        <p:txBody>
-          <a:bodyPr/>
-          <a:lstStyle/>
-          <a:p>
-            <a:r>
-              <a:rPr lang="en-US" dirty="0"/>
-              <a:t>Спікер: Залишаємо контакти й пропонуємо запустити демо просто зараз.</a:t>
-            </a:r>
-            <a:endParaRPr lang="en-US" dirty="0"/>
-          </a:p>
-        </p:txBody>
-      </p:sp>
-      <p:sp>
-        <p:nvSpPr>
-          <p:cNvPr id="4" name="Slide Number Placeholder 3"/>
-          <p:cNvSpPr>
-            <a:spLocks noGrp="1"/>
-          </p:cNvSpPr>
-          <p:nvPr>
-            <p:ph type="sldNum" sz="quarter" idx="10"/>
-          </p:nvPr>
-        </p:nvSpPr>
-        <p:spPr/>
-        <p:txBody>
-          <a:bodyPr/>
-          <a:lstStyle/>
-          <a:p>
-            <a:fld id="{F7021451-1387-4CA6-816F-3879F97B5CBC}" type="slidenum">
-              <a:rPr lang="en-US"/>
-              <a:t>19</a:t>
             </a:fld>
             <a:endParaRPr lang="en-US"/>
           </a:p>
@@ -1488,7 +597,7 @@
           <a:p>
             <a:r>
               <a:rPr lang="en-US" dirty="0"/>
-              <a:t>Спікер: Реформа 2027 — це момент, коли вибір профілю стає визначальним і коштовним. Якщо вибір помилковий, держава фінансує траєкторію, яка «не спрацює». Тому інструмент моніторингу потрібен саме зараз.</a:t>
+              <a:t>Спікер (0:25–0:50): Челендж називає три болі: дані розірвані, реакція запізніла, раннього сигналу немає. Ми додаємо четвертий — у цього є грошова ціна. Саме її покажемо.</a:t>
             </a:r>
             <a:endParaRPr lang="en-US" dirty="0"/>
           </a:p>
@@ -1576,7 +685,7 @@
           <a:p>
             <a:r>
               <a:rPr lang="en-US" dirty="0"/>
-              <a:t>Спікер: Перші три пункти — дослівно з челенджу. Четвертий — наш акцент: у фрагментованої, реактивної системи є цілком конкретна грошова ціна. Її ми зараз покажемо.</a:t>
+              <a:t>Спікер (0:50–1:15): Головна думка. Мисмеч профілю — не профорієнтаційна дрібниця. Це порушення права дитини на розвиток, яке ще й коштує державі грошей. Виявивши його рано, ми закриваємо обидва ризики одним рухом.</a:t>
             </a:r>
             <a:endParaRPr lang="en-US" dirty="0"/>
           </a:p>
@@ -1664,7 +773,7 @@
           <a:p>
             <a:r>
               <a:rPr lang="en-US" dirty="0"/>
-              <a:t>Спікер: Ось і грошовий гачок. Десятки мільярдів гривень щороку йдуть на освіту, яка не конвертується в роботу за фахом. Профільна реформа без даних ризикує відтворити цю ж проблему — лише раніше, на рівні школи. Ми навмисно показуємо діапазони й джерела: перед державним журі чесність цифр важливіша за драму.</a:t>
+              <a:t>Спікер (1:15–1:45): Кожне відомство — окремий сервіс, вони обмінюються подіями, Analysis зводить усе в прапорці й дії. Це одразу закриває всі чотири напрями челенджу. І це не слайди — це працюючий бекенд, що стартує однією командою.</a:t>
             </a:r>
             <a:endParaRPr lang="en-US" dirty="0"/>
           </a:p>
@@ -1752,7 +861,7 @@
           <a:p>
             <a:r>
               <a:rPr lang="en-US" dirty="0"/>
-              <a:t>Спікер: Головна думка пітчу. Мисмеч профілю — не «профорієнтаційна дрібниця», а порушення права дитини на розвиток, яке ще й коштує державі грошей. Один сигнал закриває обидва ризики.</a:t>
+              <a:t>Спікер (1:45–2:10): Прапорці — це світлофор із чіткою дією на кожен колір. Найважливіше: червоний автоматично перетворюється на міжвідомче направлення й кейс у соцслужбах. Прибираємо головну причину реактивності — провал координації між відомствами.</a:t>
             </a:r>
             <a:endParaRPr lang="en-US" dirty="0"/>
           </a:p>
@@ -1840,7 +949,7 @@
           <a:p>
             <a:r>
               <a:rPr lang="en-US" dirty="0"/>
-              <a:t>Спікер: Це не концепт-слайд — це працюючий бекенд. Кожне відомство — окремий сервіс, вони обмінюються подіями, а Analysis — мозок, що зводить усе в прапорці та дії.</a:t>
+              <a:t>Спікер (2:10–2:35): Наживо. Марія обрала математику, але дані показують філологію — система рекомендує правильний кластер і дає план. Олег з 20 пропусками — система сама відкриває кейс у соцслужбах. Усе наскрізно, одним скриптом.</a:t>
             </a:r>
             <a:endParaRPr lang="en-US" dirty="0"/>
           </a:p>
@@ -1928,7 +1037,7 @@
           <a:p>
             <a:r>
               <a:rPr lang="en-US" dirty="0"/>
-              <a:t>Спікер: Прямий маппінг. Жоден напрям челенджу не залишився на папері — під кожен є реальний код. Зліва — їхні слова, справа — наші артефакти.</a:t>
+              <a:t>Спікер (2:35–2:50): Навіть консервативний сценарій уперше розвертає криву «не за фахом» донизу. Кожен відсотковий пункт — це і гроші, і діти. Економіка й права тут — одне й те саме число.</a:t>
             </a:r>
             <a:endParaRPr lang="en-US" dirty="0"/>
           </a:p>
@@ -2016,7 +1125,7 @@
           <a:p>
             <a:r>
               <a:rPr lang="en-US" dirty="0"/>
-              <a:t>Спікер: Мікросервіси на чисту архітектуру. Важливо для журі: масштабованість закладена. Додати реєстр народжень чи медреєстр — це новий сервіс-продюсер, а не злам системи.</a:t>
+              <a:t>Спікер (2:50–3:00): Просимо пілот і тестові дані. Обіцяємо: ранній сигнал по кожній дитині замість реакції на кризу. Дякую — готові показати в дії.</a:t>
             </a:r>
             <a:endParaRPr lang="en-US" dirty="0"/>
           </a:p>
@@ -2040,94 +1149,6 @@
             <a:fld id="{F7021451-1387-4CA6-816F-3879F97B5CBC}" type="slidenum">
               <a:rPr lang="en-US"/>
               <a:t>8</a:t>
-            </a:fld>
-            <a:endParaRPr lang="en-US"/>
-          </a:p>
-        </p:txBody>
-      </p:sp>
-    </p:spTree>
-    <p:extLst>
-      <p:ext uri="{BB962C8B-B14F-4D97-AF65-F5344CB8AC3E}">
-        <p14:creationId xmlns:p14="http://schemas.microsoft.com/office/powerpoint/2010/main" val="1024086991"/>
-      </p:ext>
-    </p:extLst>
-  </p:cSld>
-  <p:clrMapOvr>
-    <a:masterClrMapping/>
-  </p:clrMapOvr>
-</p:notes>
-</file>
-
-<file path=ppt/notesSlides/notesSlide9.xml><?xml version="1.0" encoding="utf-8"?>
-<p:notes xmlns:a="http://schemas.openxmlformats.org/drawingml/2006/main" xmlns:r="http://schemas.openxmlformats.org/officeDocument/2006/relationships" xmlns:p="http://schemas.openxmlformats.org/presentationml/2006/main">
-  <p:cSld>
-    <p:spTree>
-      <p:nvGrpSpPr>
-        <p:cNvPr id="1" name=""/>
-        <p:cNvGrpSpPr/>
-        <p:nvPr/>
-      </p:nvGrpSpPr>
-      <p:grpSpPr>
-        <a:xfrm>
-          <a:off x="0" y="0"/>
-          <a:ext cx="0" cy="0"/>
-          <a:chOff x="0" y="0"/>
-          <a:chExt cx="0" cy="0"/>
-        </a:xfrm>
-      </p:grpSpPr>
-      <p:sp>
-        <p:nvSpPr>
-          <p:cNvPr id="2" name="Slide Image Placeholder 1"/>
-          <p:cNvSpPr>
-            <a:spLocks noGrp="1" noRot="1" noChangeAspect="1"/>
-          </p:cNvSpPr>
-          <p:nvPr>
-            <p:ph type="sldImg"/>
-          </p:nvPr>
-        </p:nvSpPr>
-        <p:spPr/>
-      </p:sp>
-      <p:sp>
-        <p:nvSpPr>
-          <p:cNvPr id="3" name="Notes Placeholder 2"/>
-          <p:cNvSpPr>
-            <a:spLocks noGrp="1"/>
-          </p:cNvSpPr>
-          <p:nvPr>
-            <p:ph type="body" idx="1"/>
-          </p:nvPr>
-        </p:nvSpPr>
-        <p:spPr/>
-        <p:txBody>
-          <a:bodyPr/>
-          <a:lstStyle/>
-          <a:p>
-            <a:r>
-              <a:rPr lang="en-US" dirty="0"/>
-              <a:t>Спікер: Челендж хоче траєкторію «від народження». Ми чесні: найглибше зробили шкільно-профільний сегмент, бо там реформа і там гроші. Але архітектура — це конвеєр подій, у який інші реєстри вмикаються природно.</a:t>
-            </a:r>
-            <a:endParaRPr lang="en-US" dirty="0"/>
-          </a:p>
-        </p:txBody>
-      </p:sp>
-      <p:sp>
-        <p:nvSpPr>
-          <p:cNvPr id="4" name="Slide Number Placeholder 3"/>
-          <p:cNvSpPr>
-            <a:spLocks noGrp="1"/>
-          </p:cNvSpPr>
-          <p:nvPr>
-            <p:ph type="sldNum" sz="quarter" idx="10"/>
-          </p:nvPr>
-        </p:nvSpPr>
-        <p:spPr/>
-        <p:txBody>
-          <a:bodyPr/>
-          <a:lstStyle/>
-          <a:p>
-            <a:fld id="{F7021451-1387-4CA6-816F-3879F97B5CBC}" type="slidenum">
-              <a:rPr lang="en-US"/>
-              <a:t>9</a:t>
             </a:fld>
             <a:endParaRPr lang="en-US"/>
           </a:p>
@@ -2456,396 +1477,6 @@
 <file path=ppt/slides/slide1.xml><?xml version="1.0" encoding="utf-8"?>
 <p:sld xmlns:a="http://schemas.openxmlformats.org/drawingml/2006/main" xmlns:r="http://schemas.openxmlformats.org/officeDocument/2006/relationships" xmlns:p="http://schemas.openxmlformats.org/presentationml/2006/main">
   <p:cSld name="Slide 1">
-    <p:bg>
-      <p:bgPr>
-        <a:blipFill dpi="0" rotWithShape="1">
-          <a:blip r:embed="rId1">
-            <a:lum/>
-          </a:blip>
-          <a:srcRect/>
-          <a:stretch>
-            <a:fillRect/>
-          </a:stretch>
-        </a:blipFill>
-        <a:effectLst/>
-      </p:bgPr>
-    </p:bg>
-    <p:spTree>
-      <p:nvGrpSpPr>
-        <p:cNvPr id="1" name=""/>
-        <p:cNvGrpSpPr/>
-        <p:nvPr/>
-      </p:nvGrpSpPr>
-      <p:grpSpPr>
-        <a:xfrm>
-          <a:off x="0" y="0"/>
-          <a:ext cx="0" cy="0"/>
-          <a:chOff x="0" y="0"/>
-          <a:chExt cx="0" cy="0"/>
-        </a:xfrm>
-      </p:grpSpPr>
-    </p:spTree>
-  </p:cSld>
-  <p:clrMapOvr>
-    <a:masterClrMapping/>
-  </p:clrMapOvr>
-</p:sld>
-</file>
-
-<file path=ppt/slides/slide10.xml><?xml version="1.0" encoding="utf-8"?>
-<p:sld xmlns:a="http://schemas.openxmlformats.org/drawingml/2006/main" xmlns:r="http://schemas.openxmlformats.org/officeDocument/2006/relationships" xmlns:p="http://schemas.openxmlformats.org/presentationml/2006/main">
-  <p:cSld name="Slide 10">
-    <p:bg>
-      <p:bgPr>
-        <a:blipFill dpi="0" rotWithShape="1">
-          <a:blip r:embed="rId1">
-            <a:lum/>
-          </a:blip>
-          <a:srcRect/>
-          <a:stretch>
-            <a:fillRect/>
-          </a:stretch>
-        </a:blipFill>
-        <a:effectLst/>
-      </p:bgPr>
-    </p:bg>
-    <p:spTree>
-      <p:nvGrpSpPr>
-        <p:cNvPr id="1" name=""/>
-        <p:cNvGrpSpPr/>
-        <p:nvPr/>
-      </p:nvGrpSpPr>
-      <p:grpSpPr>
-        <a:xfrm>
-          <a:off x="0" y="0"/>
-          <a:ext cx="0" cy="0"/>
-          <a:chOff x="0" y="0"/>
-          <a:chExt cx="0" cy="0"/>
-        </a:xfrm>
-      </p:grpSpPr>
-    </p:spTree>
-  </p:cSld>
-  <p:clrMapOvr>
-    <a:masterClrMapping/>
-  </p:clrMapOvr>
-</p:sld>
-</file>
-
-<file path=ppt/slides/slide11.xml><?xml version="1.0" encoding="utf-8"?>
-<p:sld xmlns:a="http://schemas.openxmlformats.org/drawingml/2006/main" xmlns:r="http://schemas.openxmlformats.org/officeDocument/2006/relationships" xmlns:p="http://schemas.openxmlformats.org/presentationml/2006/main">
-  <p:cSld name="Slide 11">
-    <p:bg>
-      <p:bgPr>
-        <a:blipFill dpi="0" rotWithShape="1">
-          <a:blip r:embed="rId1">
-            <a:lum/>
-          </a:blip>
-          <a:srcRect/>
-          <a:stretch>
-            <a:fillRect/>
-          </a:stretch>
-        </a:blipFill>
-        <a:effectLst/>
-      </p:bgPr>
-    </p:bg>
-    <p:spTree>
-      <p:nvGrpSpPr>
-        <p:cNvPr id="1" name=""/>
-        <p:cNvGrpSpPr/>
-        <p:nvPr/>
-      </p:nvGrpSpPr>
-      <p:grpSpPr>
-        <a:xfrm>
-          <a:off x="0" y="0"/>
-          <a:ext cx="0" cy="0"/>
-          <a:chOff x="0" y="0"/>
-          <a:chExt cx="0" cy="0"/>
-        </a:xfrm>
-      </p:grpSpPr>
-    </p:spTree>
-  </p:cSld>
-  <p:clrMapOvr>
-    <a:masterClrMapping/>
-  </p:clrMapOvr>
-</p:sld>
-</file>
-
-<file path=ppt/slides/slide12.xml><?xml version="1.0" encoding="utf-8"?>
-<p:sld xmlns:a="http://schemas.openxmlformats.org/drawingml/2006/main" xmlns:r="http://schemas.openxmlformats.org/officeDocument/2006/relationships" xmlns:p="http://schemas.openxmlformats.org/presentationml/2006/main">
-  <p:cSld name="Slide 12">
-    <p:bg>
-      <p:bgPr>
-        <a:blipFill dpi="0" rotWithShape="1">
-          <a:blip r:embed="rId1">
-            <a:lum/>
-          </a:blip>
-          <a:srcRect/>
-          <a:stretch>
-            <a:fillRect/>
-          </a:stretch>
-        </a:blipFill>
-        <a:effectLst/>
-      </p:bgPr>
-    </p:bg>
-    <p:spTree>
-      <p:nvGrpSpPr>
-        <p:cNvPr id="1" name=""/>
-        <p:cNvGrpSpPr/>
-        <p:nvPr/>
-      </p:nvGrpSpPr>
-      <p:grpSpPr>
-        <a:xfrm>
-          <a:off x="0" y="0"/>
-          <a:ext cx="0" cy="0"/>
-          <a:chOff x="0" y="0"/>
-          <a:chExt cx="0" cy="0"/>
-        </a:xfrm>
-      </p:grpSpPr>
-    </p:spTree>
-  </p:cSld>
-  <p:clrMapOvr>
-    <a:masterClrMapping/>
-  </p:clrMapOvr>
-</p:sld>
-</file>
-
-<file path=ppt/slides/slide13.xml><?xml version="1.0" encoding="utf-8"?>
-<p:sld xmlns:a="http://schemas.openxmlformats.org/drawingml/2006/main" xmlns:r="http://schemas.openxmlformats.org/officeDocument/2006/relationships" xmlns:p="http://schemas.openxmlformats.org/presentationml/2006/main">
-  <p:cSld name="Slide 13">
-    <p:bg>
-      <p:bgPr>
-        <a:blipFill dpi="0" rotWithShape="1">
-          <a:blip r:embed="rId1">
-            <a:lum/>
-          </a:blip>
-          <a:srcRect/>
-          <a:stretch>
-            <a:fillRect/>
-          </a:stretch>
-        </a:blipFill>
-        <a:effectLst/>
-      </p:bgPr>
-    </p:bg>
-    <p:spTree>
-      <p:nvGrpSpPr>
-        <p:cNvPr id="1" name=""/>
-        <p:cNvGrpSpPr/>
-        <p:nvPr/>
-      </p:nvGrpSpPr>
-      <p:grpSpPr>
-        <a:xfrm>
-          <a:off x="0" y="0"/>
-          <a:ext cx="0" cy="0"/>
-          <a:chOff x="0" y="0"/>
-          <a:chExt cx="0" cy="0"/>
-        </a:xfrm>
-      </p:grpSpPr>
-    </p:spTree>
-  </p:cSld>
-  <p:clrMapOvr>
-    <a:masterClrMapping/>
-  </p:clrMapOvr>
-</p:sld>
-</file>
-
-<file path=ppt/slides/slide14.xml><?xml version="1.0" encoding="utf-8"?>
-<p:sld xmlns:a="http://schemas.openxmlformats.org/drawingml/2006/main" xmlns:r="http://schemas.openxmlformats.org/officeDocument/2006/relationships" xmlns:p="http://schemas.openxmlformats.org/presentationml/2006/main">
-  <p:cSld name="Slide 14">
-    <p:bg>
-      <p:bgPr>
-        <a:blipFill dpi="0" rotWithShape="1">
-          <a:blip r:embed="rId1">
-            <a:lum/>
-          </a:blip>
-          <a:srcRect/>
-          <a:stretch>
-            <a:fillRect/>
-          </a:stretch>
-        </a:blipFill>
-        <a:effectLst/>
-      </p:bgPr>
-    </p:bg>
-    <p:spTree>
-      <p:nvGrpSpPr>
-        <p:cNvPr id="1" name=""/>
-        <p:cNvGrpSpPr/>
-        <p:nvPr/>
-      </p:nvGrpSpPr>
-      <p:grpSpPr>
-        <a:xfrm>
-          <a:off x="0" y="0"/>
-          <a:ext cx="0" cy="0"/>
-          <a:chOff x="0" y="0"/>
-          <a:chExt cx="0" cy="0"/>
-        </a:xfrm>
-      </p:grpSpPr>
-    </p:spTree>
-  </p:cSld>
-  <p:clrMapOvr>
-    <a:masterClrMapping/>
-  </p:clrMapOvr>
-</p:sld>
-</file>
-
-<file path=ppt/slides/slide15.xml><?xml version="1.0" encoding="utf-8"?>
-<p:sld xmlns:a="http://schemas.openxmlformats.org/drawingml/2006/main" xmlns:r="http://schemas.openxmlformats.org/officeDocument/2006/relationships" xmlns:p="http://schemas.openxmlformats.org/presentationml/2006/main">
-  <p:cSld name="Slide 15">
-    <p:bg>
-      <p:bgPr>
-        <a:blipFill dpi="0" rotWithShape="1">
-          <a:blip r:embed="rId1">
-            <a:lum/>
-          </a:blip>
-          <a:srcRect/>
-          <a:stretch>
-            <a:fillRect/>
-          </a:stretch>
-        </a:blipFill>
-        <a:effectLst/>
-      </p:bgPr>
-    </p:bg>
-    <p:spTree>
-      <p:nvGrpSpPr>
-        <p:cNvPr id="1" name=""/>
-        <p:cNvGrpSpPr/>
-        <p:nvPr/>
-      </p:nvGrpSpPr>
-      <p:grpSpPr>
-        <a:xfrm>
-          <a:off x="0" y="0"/>
-          <a:ext cx="0" cy="0"/>
-          <a:chOff x="0" y="0"/>
-          <a:chExt cx="0" cy="0"/>
-        </a:xfrm>
-      </p:grpSpPr>
-    </p:spTree>
-  </p:cSld>
-  <p:clrMapOvr>
-    <a:masterClrMapping/>
-  </p:clrMapOvr>
-</p:sld>
-</file>
-
-<file path=ppt/slides/slide16.xml><?xml version="1.0" encoding="utf-8"?>
-<p:sld xmlns:a="http://schemas.openxmlformats.org/drawingml/2006/main" xmlns:r="http://schemas.openxmlformats.org/officeDocument/2006/relationships" xmlns:p="http://schemas.openxmlformats.org/presentationml/2006/main">
-  <p:cSld name="Slide 16">
-    <p:bg>
-      <p:bgPr>
-        <a:blipFill dpi="0" rotWithShape="1">
-          <a:blip r:embed="rId1">
-            <a:lum/>
-          </a:blip>
-          <a:srcRect/>
-          <a:stretch>
-            <a:fillRect/>
-          </a:stretch>
-        </a:blipFill>
-        <a:effectLst/>
-      </p:bgPr>
-    </p:bg>
-    <p:spTree>
-      <p:nvGrpSpPr>
-        <p:cNvPr id="1" name=""/>
-        <p:cNvGrpSpPr/>
-        <p:nvPr/>
-      </p:nvGrpSpPr>
-      <p:grpSpPr>
-        <a:xfrm>
-          <a:off x="0" y="0"/>
-          <a:ext cx="0" cy="0"/>
-          <a:chOff x="0" y="0"/>
-          <a:chExt cx="0" cy="0"/>
-        </a:xfrm>
-      </p:grpSpPr>
-    </p:spTree>
-  </p:cSld>
-  <p:clrMapOvr>
-    <a:masterClrMapping/>
-  </p:clrMapOvr>
-</p:sld>
-</file>
-
-<file path=ppt/slides/slide17.xml><?xml version="1.0" encoding="utf-8"?>
-<p:sld xmlns:a="http://schemas.openxmlformats.org/drawingml/2006/main" xmlns:r="http://schemas.openxmlformats.org/officeDocument/2006/relationships" xmlns:p="http://schemas.openxmlformats.org/presentationml/2006/main">
-  <p:cSld name="Slide 17">
-    <p:bg>
-      <p:bgPr>
-        <a:blipFill dpi="0" rotWithShape="1">
-          <a:blip r:embed="rId1">
-            <a:lum/>
-          </a:blip>
-          <a:srcRect/>
-          <a:stretch>
-            <a:fillRect/>
-          </a:stretch>
-        </a:blipFill>
-        <a:effectLst/>
-      </p:bgPr>
-    </p:bg>
-    <p:spTree>
-      <p:nvGrpSpPr>
-        <p:cNvPr id="1" name=""/>
-        <p:cNvGrpSpPr/>
-        <p:nvPr/>
-      </p:nvGrpSpPr>
-      <p:grpSpPr>
-        <a:xfrm>
-          <a:off x="0" y="0"/>
-          <a:ext cx="0" cy="0"/>
-          <a:chOff x="0" y="0"/>
-          <a:chExt cx="0" cy="0"/>
-        </a:xfrm>
-      </p:grpSpPr>
-    </p:spTree>
-  </p:cSld>
-  <p:clrMapOvr>
-    <a:masterClrMapping/>
-  </p:clrMapOvr>
-</p:sld>
-</file>
-
-<file path=ppt/slides/slide18.xml><?xml version="1.0" encoding="utf-8"?>
-<p:sld xmlns:a="http://schemas.openxmlformats.org/drawingml/2006/main" xmlns:r="http://schemas.openxmlformats.org/officeDocument/2006/relationships" xmlns:p="http://schemas.openxmlformats.org/presentationml/2006/main">
-  <p:cSld name="Slide 18">
-    <p:bg>
-      <p:bgPr>
-        <a:blipFill dpi="0" rotWithShape="1">
-          <a:blip r:embed="rId1">
-            <a:lum/>
-          </a:blip>
-          <a:srcRect/>
-          <a:stretch>
-            <a:fillRect/>
-          </a:stretch>
-        </a:blipFill>
-        <a:effectLst/>
-      </p:bgPr>
-    </p:bg>
-    <p:spTree>
-      <p:nvGrpSpPr>
-        <p:cNvPr id="1" name=""/>
-        <p:cNvGrpSpPr/>
-        <p:nvPr/>
-      </p:nvGrpSpPr>
-      <p:grpSpPr>
-        <a:xfrm>
-          <a:off x="0" y="0"/>
-          <a:ext cx="0" cy="0"/>
-          <a:chOff x="0" y="0"/>
-          <a:chExt cx="0" cy="0"/>
-        </a:xfrm>
-      </p:grpSpPr>
-    </p:spTree>
-  </p:cSld>
-  <p:clrMapOvr>
-    <a:masterClrMapping/>
-  </p:clrMapOvr>
-</p:sld>
-</file>
-
-<file path=ppt/slides/slide19.xml><?xml version="1.0" encoding="utf-8"?>
-<p:sld xmlns:a="http://schemas.openxmlformats.org/drawingml/2006/main" xmlns:r="http://schemas.openxmlformats.org/officeDocument/2006/relationships" xmlns:p="http://schemas.openxmlformats.org/presentationml/2006/main">
-  <p:cSld name="Slide 19">
     <p:bg>
       <p:bgPr>
         <a:blipFill dpi="0" rotWithShape="1">
@@ -3155,45 +1786,6 @@
 </p:sld>
 </file>
 
-<file path=ppt/slides/slide9.xml><?xml version="1.0" encoding="utf-8"?>
-<p:sld xmlns:a="http://schemas.openxmlformats.org/drawingml/2006/main" xmlns:r="http://schemas.openxmlformats.org/officeDocument/2006/relationships" xmlns:p="http://schemas.openxmlformats.org/presentationml/2006/main">
-  <p:cSld name="Slide 9">
-    <p:bg>
-      <p:bgPr>
-        <a:blipFill dpi="0" rotWithShape="1">
-          <a:blip r:embed="rId1">
-            <a:lum/>
-          </a:blip>
-          <a:srcRect/>
-          <a:stretch>
-            <a:fillRect/>
-          </a:stretch>
-        </a:blipFill>
-        <a:effectLst/>
-      </p:bgPr>
-    </p:bg>
-    <p:spTree>
-      <p:nvGrpSpPr>
-        <p:cNvPr id="1" name=""/>
-        <p:cNvGrpSpPr/>
-        <p:nvPr/>
-      </p:nvGrpSpPr>
-      <p:grpSpPr>
-        <a:xfrm>
-          <a:off x="0" y="0"/>
-          <a:ext cx="0" cy="0"/>
-          <a:chOff x="0" y="0"/>
-          <a:chExt cx="0" cy="0"/>
-        </a:xfrm>
-      </p:grpSpPr>
-    </p:spTree>
-  </p:cSld>
-  <p:clrMapOvr>
-    <a:masterClrMapping/>
-  </p:clrMapOvr>
-</p:sld>
-</file>
-
 <file path=ppt/theme/theme1.xml><?xml version="1.0" encoding="utf-8"?>
 <a:theme xmlns:a="http://schemas.openxmlformats.org/drawingml/2006/main" name="Office Theme">
   <a:themeElements>

</xml_diff>